<commit_message>
Add interactive RDQA demo link to all application documents
Added https://rdqa-demo.vercel.app/ demo dashboard reference to:
- Technical Proposal (DOCX): Executive Summary, Digital Tools section, signature area
- Budget (XLSX): Footer of both Budget Summary and Monthly Breakdown sheets
- Inception Report (PPTX): Title slide, Digital Tools slide, Next Steps/Contact slide
- Regenerated PDF from updated DOCX with all demo references

https://claude.ai/code/session_015BtjMoQbpeJ26zz4ypTTxf
</commit_message>
<xml_diff>
--- a/docs/Tiko_RDQA_Inception_Report_2026.pptx
+++ b/docs/Tiko_RDQA_Inception_Report_2026.pptx
@@ -1873,6 +1873,10 @@
           </a:solidFill>
           <a:ln/>
         </p:spPr>
+        <p:txBody>
+          <a:bodyPr/>
+          <a:p/>
+        </p:txBody>
       </p:sp>
       <p:sp>
         <p:nvSpPr>
@@ -1893,6 +1897,10 @@
           </a:solidFill>
           <a:ln/>
         </p:spPr>
+        <p:txBody>
+          <a:bodyPr/>
+          <a:p/>
+        </p:txBody>
       </p:sp>
       <p:sp>
         <p:nvSpPr>
@@ -2069,6 +2077,10 @@
           </a:solidFill>
           <a:ln/>
         </p:spPr>
+        <p:txBody>
+          <a:bodyPr/>
+          <a:p/>
+        </p:txBody>
       </p:sp>
       <p:sp>
         <p:nvSpPr>
@@ -2184,6 +2196,17 @@
               <a:t>13 February 2026</a:t>
             </a:r>
             <a:endParaRPr lang="en-US" sz="1200" dirty="0"/>
+          </a:p>
+          <a:p>
+            <a:pPr algn="ctr"/>
+            <a:r>
+              <a:rPr sz="1000" i="1">
+                <a:solidFill>
+                  <a:srgbClr val="66C2A5"/>
+                </a:solidFill>
+              </a:rPr>
+              <a:t>Interactive Demo: rdqa-demo.vercel.app</a:t>
+            </a:r>
           </a:p>
         </p:txBody>
       </p:sp>
@@ -4821,6 +4844,10 @@
           </a:solidFill>
           <a:ln/>
         </p:spPr>
+        <p:txBody>
+          <a:bodyPr/>
+          <a:p/>
+        </p:txBody>
       </p:sp>
       <p:sp>
         <p:nvSpPr>
@@ -4880,6 +4907,10 @@
           </a:solidFill>
           <a:ln/>
         </p:spPr>
+        <p:txBody>
+          <a:bodyPr/>
+          <a:p/>
+        </p:txBody>
       </p:sp>
       <p:sp>
         <p:nvSpPr>
@@ -5056,6 +5087,10 @@
           </a:solidFill>
           <a:ln/>
         </p:spPr>
+        <p:txBody>
+          <a:bodyPr/>
+          <a:p/>
+        </p:txBody>
       </p:sp>
       <p:sp>
         <p:nvSpPr>
@@ -5232,6 +5267,10 @@
           </a:solidFill>
           <a:ln/>
         </p:spPr>
+        <p:txBody>
+          <a:bodyPr/>
+          <a:p/>
+        </p:txBody>
       </p:sp>
       <p:sp>
         <p:nvSpPr>
@@ -5408,6 +5447,10 @@
           </a:solidFill>
           <a:ln/>
         </p:spPr>
+        <p:txBody>
+          <a:bodyPr/>
+          <a:p/>
+        </p:txBody>
       </p:sp>
       <p:sp>
         <p:nvSpPr>
@@ -5584,6 +5627,10 @@
           </a:solidFill>
           <a:ln/>
         </p:spPr>
+        <p:txBody>
+          <a:bodyPr/>
+          <a:p/>
+        </p:txBody>
       </p:sp>
       <p:sp>
         <p:nvSpPr>
@@ -5621,6 +5668,17 @@
               <a:t>Paul Mubiri: mubirip@gmail.com  |  +256 754 544 660     •     Raymond Wayesu: raymondrwayesu@gmail.com  |  +256 784 902 753</a:t>
             </a:r>
             <a:endParaRPr lang="en-US" sz="1000" dirty="0"/>
+          </a:p>
+          <a:p>
+            <a:pPr algn="ctr"/>
+            <a:r>
+              <a:rPr sz="1000" b="1">
+                <a:solidFill>
+                  <a:srgbClr val="2B6CB0"/>
+                </a:solidFill>
+              </a:rPr>
+              <a:t>Interactive RDQA Demo: https://rdqa-demo.vercel.app/</a:t>
+            </a:r>
           </a:p>
         </p:txBody>
       </p:sp>
@@ -17029,6 +17087,10 @@
           </a:solidFill>
           <a:ln/>
         </p:spPr>
+        <p:txBody>
+          <a:bodyPr/>
+          <a:p/>
+        </p:txBody>
       </p:sp>
       <p:sp>
         <p:nvSpPr>
@@ -17095,6 +17157,10 @@
             </a:outerShdw>
           </a:effectLst>
         </p:spPr>
+        <p:txBody>
+          <a:bodyPr/>
+          <a:p/>
+        </p:txBody>
       </p:sp>
       <p:sp>
         <p:nvSpPr>
@@ -17115,6 +17181,10 @@
           </a:solidFill>
           <a:ln/>
         </p:spPr>
+        <p:txBody>
+          <a:bodyPr/>
+          <a:p/>
+        </p:txBody>
       </p:sp>
       <p:pic>
         <p:nvPicPr>
@@ -17667,6 +17737,10 @@
             </a:outerShdw>
           </a:effectLst>
         </p:spPr>
+        <p:txBody>
+          <a:bodyPr/>
+          <a:p/>
+        </p:txBody>
       </p:sp>
       <p:sp>
         <p:nvSpPr>
@@ -17687,6 +17761,10 @@
           </a:solidFill>
           <a:ln/>
         </p:spPr>
+        <p:txBody>
+          <a:bodyPr/>
+          <a:p/>
+        </p:txBody>
       </p:sp>
       <p:sp>
         <p:nvSpPr>
@@ -17763,6 +17841,10 @@
           </a:solidFill>
           <a:ln/>
         </p:spPr>
+        <p:txBody>
+          <a:bodyPr/>
+          <a:p/>
+        </p:txBody>
       </p:sp>
       <p:sp>
         <p:nvSpPr>
@@ -17900,6 +17982,10 @@
           </a:solidFill>
           <a:ln/>
         </p:spPr>
+        <p:txBody>
+          <a:bodyPr/>
+          <a:p/>
+        </p:txBody>
       </p:sp>
       <p:sp>
         <p:nvSpPr>
@@ -18037,6 +18123,10 @@
           </a:solidFill>
           <a:ln/>
         </p:spPr>
+        <p:txBody>
+          <a:bodyPr/>
+          <a:p/>
+        </p:txBody>
       </p:sp>
       <p:sp>
         <p:nvSpPr>
@@ -18174,6 +18264,10 @@
           </a:solidFill>
           <a:ln/>
         </p:spPr>
+        <p:txBody>
+          <a:bodyPr/>
+          <a:p/>
+        </p:txBody>
       </p:sp>
       <p:sp>
         <p:nvSpPr>
@@ -18328,6 +18422,43 @@
               <a:t>Cost: Free humanitarian tier (5,000 submissions/month, 1 GB storage)</a:t>
             </a:r>
             <a:endParaRPr lang="en-US" sz="850" dirty="0"/>
+          </a:p>
+          <a:p>
+            <a:pPr>
+              <a:spcBef>
+                <a:spcPts val="800"/>
+              </a:spcBef>
+            </a:pPr>
+          </a:p>
+          <a:p>
+            <a:pPr algn="l"/>
+            <a:r>
+              <a:rPr sz="1100" b="1">
+                <a:solidFill>
+                  <a:srgbClr val="1A365D"/>
+                </a:solidFill>
+              </a:rPr>
+              <a:t>RDQA Demo Dashboard</a:t>
+            </a:r>
+          </a:p>
+          <a:p>
+            <a:pPr algn="l"/>
+            <a:r>
+              <a:rPr sz="900">
+                <a:solidFill>
+                  <a:srgbClr val="4A5568"/>
+                </a:solidFill>
+              </a:rPr>
+              <a:t>Interactive demonstration of our analytical outputs — VF charts, spider diagrams, root cause analysis, and three-way data triangulation: </a:t>
+            </a:r>
+            <a:r>
+              <a:rPr sz="900" b="1" u="sng">
+                <a:solidFill>
+                  <a:srgbClr val="2B6CB0"/>
+                </a:solidFill>
+              </a:rPr>
+              <a:t>https://rdqa-demo.vercel.app/</a:t>
+            </a:r>
           </a:p>
         </p:txBody>
       </p:sp>

</xml_diff>

<commit_message>
Add RDQA Web Tool link to all Tiko application documents
Added the live R/Shiny RDQA Web Tool link
(https://dnfxdz-raymond-wayesu.shinyapps.io/rdqa-web-tool/)
alongside the existing demo dashboard link in all three documents,
with an explanation of the difference between the two:

- Demo dashboard (rdqa-demo.vercel.app): static Next.js website
  showcasing methodology and sample outputs
- RDQA Web Tool (shinyapps.io): live interactive R/Shiny app with
  real-time VF computation, DHIS2 integration, and report generation

Files updated:
- Technical Proposal (.docx): Executive Summary, Section 3.7, footer
- Inception Report (.pptx): Slides 1, 9, 12
- Budget (.xlsx): Both Budget Summary and Monthly Breakdown sheets

Note: The PDF needs to be regenerated locally from the updated DOCX.

https://claude.ai/code/session_015BtjMoQbpeJ26zz4ypTTxf
</commit_message>
<xml_diff>
--- a/docs/Tiko_RDQA_Inception_Report_2026.pptx
+++ b/docs/Tiko_RDQA_Inception_Report_2026.pptx
@@ -2208,6 +2208,16 @@
               <a:t>Interactive Demo: rdqa-demo.vercel.app</a:t>
             </a:r>
           </a:p>
+          <a:p>
+            <a:r>
+              <a:rPr lang="en-US" dirty="0" sz="127000">
+                <a:solidFill>
+                  <a:srgbClr val="66C2A5"/>
+                </a:solidFill>
+              </a:rPr>
+              <a:t>RDQA Web Tool: dnfxdz-raymond-wayesu.shinyapps.io/rdqa-web-tool/</a:t>
+            </a:r>
+          </a:p>
         </p:txBody>
       </p:sp>
     </p:spTree>
@@ -5678,6 +5688,16 @@
                 </a:solidFill>
               </a:rPr>
               <a:t>Interactive RDQA Demo: https://rdqa-demo.vercel.app/</a:t>
+            </a:r>
+          </a:p>
+          <a:p>
+            <a:r>
+              <a:rPr lang="en-US" dirty="0" b="1" sz="127000">
+                <a:solidFill>
+                  <a:srgbClr val="2B6CB0"/>
+                </a:solidFill>
+              </a:rPr>
+              <a:t>RDQA Web Tool (R/Shiny): https://dnfxdz-raymond-wayesu.shinyapps.io/rdqa-web-tool/</a:t>
             </a:r>
           </a:p>
         </p:txBody>
@@ -18458,6 +18478,35 @@
                 </a:solidFill>
               </a:rPr>
               <a:t>https://rdqa-demo.vercel.app/</a:t>
+            </a:r>
+          </a:p>
+          <a:p/>
+          <a:p>
+            <a:r>
+              <a:rPr lang="en-US" dirty="0" b="1" sz="139700">
+                <a:solidFill>
+                  <a:srgbClr val="1A365D"/>
+                </a:solidFill>
+              </a:rPr>
+              <a:t>RDQA Web Tool (R/Shiny)</a:t>
+            </a:r>
+          </a:p>
+          <a:p>
+            <a:r>
+              <a:rPr lang="en-US" dirty="0" sz="114300">
+                <a:solidFill>
+                  <a:srgbClr val="4A5568"/>
+                </a:solidFill>
+              </a:rPr>
+              <a:t>Live interactive application for real-time VF computation, M&amp;E systems assessment, datimvalidation checks, and report generation — supports demo mode and live DHIS2 integration: </a:t>
+            </a:r>
+            <a:r>
+              <a:rPr lang="en-US" dirty="0" b="1" sz="114300">
+                <a:solidFill>
+                  <a:srgbClr val="2B6CB0"/>
+                </a:solidFill>
+              </a:rPr>
+              <a:t>https://dnfxdz-raymond-wayesu.shinyapps.io/rdqa-web-tool/</a:t>
             </a:r>
           </a:p>
         </p:txBody>

</xml_diff>

<commit_message>
Update application documents with adjusted budget and CV data
- Replace budget with Paul's adjusted figures ($120/day lead, $100/day analyst,
  5 days/month, transport $0, grand total USD 11,650)
- Update team bios in proposal and presentation with details from new CVs
- Revise team composition to lean two-person core team approach
- Update budget framework section with simplified 4-category structure
- Generate Raymond's RDQA-tailored CV (DOCX + PDF) highlighting data quality,
  health M&E, HMIS, and statistical analysis experience
- Regenerate proposal PDF from updated DOCX

https://claude.ai/code/session_015BtjMoQbpeJ26zz4ypTTxf
</commit_message>
<xml_diff>
--- a/docs/Tiko_RDQA_Inception_Report_2026.pptx
+++ b/docs/Tiko_RDQA_Inception_Report_2026.pptx
@@ -7961,6 +7961,10 @@
           </a:solidFill>
           <a:ln/>
         </p:spPr>
+        <p:txBody>
+          <a:bodyPr/>
+          <a:p/>
+        </p:txBody>
       </p:sp>
       <p:sp>
         <p:nvSpPr>
@@ -8027,6 +8031,10 @@
             </a:outerShdw>
           </a:effectLst>
         </p:spPr>
+        <p:txBody>
+          <a:bodyPr/>
+          <a:p/>
+        </p:txBody>
       </p:sp>
       <p:sp>
         <p:nvSpPr>
@@ -8047,6 +8055,10 @@
           </a:solidFill>
           <a:ln/>
         </p:spPr>
+        <p:txBody>
+          <a:bodyPr/>
+          <a:p/>
+        </p:txBody>
       </p:sp>
       <p:pic>
         <p:nvPicPr>
@@ -8385,6 +8397,10 @@
             </a:outerShdw>
           </a:effectLst>
         </p:spPr>
+        <p:txBody>
+          <a:bodyPr/>
+          <a:p/>
+        </p:txBody>
       </p:sp>
       <p:sp>
         <p:nvSpPr>
@@ -8405,6 +8421,10 @@
           </a:solidFill>
           <a:ln/>
         </p:spPr>
+        <p:txBody>
+          <a:bodyPr/>
+          <a:p/>
+        </p:txBody>
       </p:sp>
       <p:pic>
         <p:nvPicPr>
@@ -8736,6 +8756,10 @@
           </a:solidFill>
           <a:ln/>
         </p:spPr>
+        <p:txBody>
+          <a:bodyPr/>
+          <a:p/>
+        </p:txBody>
       </p:sp>
       <p:sp>
         <p:nvSpPr>
@@ -8762,15 +8786,8 @@
               <a:buNone/>
             </a:pPr>
             <a:r>
-              <a:rPr lang="en-US" sz="1000" dirty="0">
-                <a:solidFill>
-                  <a:srgbClr val="1B3A4B"/>
-                </a:solidFill>
-                <a:latin typeface="Calibri" pitchFamily="34" charset="0"/>
-                <a:ea typeface="Calibri" pitchFamily="34" charset="-122"/>
-                <a:cs typeface="Calibri" pitchFamily="34" charset="-120"/>
-              </a:rPr>
-              <a:t>+ 2–4 Field Data Quality Auditors (to be recruited during inception; bachelor’s degree, 3+ years HMIS experience, Kampala/Wakiso-based)</a:t>
+              <a:rPr sz="1000" i="1"/>
+              <a:t>Core two-person team; additional field support to be mobilised if facility volume requires (Kampala/Wakiso-based, 3+ years HMIS experience)</a:t>
             </a:r>
             <a:endParaRPr lang="en-US" sz="1000" dirty="0"/>
           </a:p>

</xml_diff>